<commit_message>
Add precision medicine, products/stages, team section, and Google content to website; update Manasa phone across all files
- index.html: Added 4 major new sections (precision medicine, products with dev stages, team bios, company info)
- about.html: Added Manasa Jampani phone (469) 499-6435 to footer contact
- contact.html: Added Manasa phone to contact page
- google-cloud-email-response.html: Updated Manasa contact block with correct phone
- ardia-profile.html: Updated Manasa phone reference
- Ardia_Health_Pitch_Deck_2026_v2.pptx: Rebuilt with precision medicine, all 4 product modules, corrected team titles/phones
- Ardia_Health_Business_Plan_2026_v2.docx: Rebuilt with precision medicine, Google-required sections, corrected team info

Co-Authored-By: Claude Sonnet 4.6 <noreply@anthropic.com>
</commit_message>
<xml_diff>
--- a/Ardia_Health_Pitch_Deck_2026_v2.pptx
+++ b/Ardia_Health_Pitch_Deck_2026_v2.pptx
@@ -6577,7 +6577,7 @@
                 <a:ea typeface="Calibri" pitchFamily="34" charset="-122"/>
                 <a:cs typeface="Calibri" pitchFamily="34" charset="-120"/>
               </a:rPr>
-              <a:t>(469) 679-3334  |  ardiahealthlabs.com  |  Argyle, TX 76226 (DFW Metro)</a:t>
+              <a:t>(469) 679-3334 (Ram)  ·  (469) 499-6435 (Manasa)  |  ardiahealthlabs.com  |  Argyle, TX 76226</a:t>
             </a:r>
             <a:endParaRPr lang="en-US" sz="1050" dirty="0"/>
           </a:p>
@@ -13881,7 +13881,7 @@
                 <a:ea typeface="Calibri" pitchFamily="34" charset="-122"/>
                 <a:cs typeface="Calibri" pitchFamily="34" charset="-120"/>
               </a:rPr>
-              <a:t>▸  Contact: founders@ardiahealthlabs.com</a:t>
+              <a:t>▸  founders@ardiahealthlabs.com  |  (469) 499-6435</a:t>
             </a:r>
             <a:endParaRPr lang="en-US" sz="950" dirty="0"/>
           </a:p>

</xml_diff>